<commit_message>
Show classes and usage for each OOP concept in the presentation
Slide 4 now lists the package and classes behind each OOP concept
with a one-line explanation of how it is applied.

Co-Authored-By: Claude Opus 5.5 <noreply@anthropic.com>
Claude-Session: https://claude.ai/code/session_01YZnTLcTjQZ5JPmHn3ARFpc
</commit_message>
<xml_diff>
--- a/docs/Rock-Paper-Scissors-Presentation.pptx
+++ b/docs/Rock-Paper-Scissors-Presentation.pptx
@@ -111,19 +111,19 @@
   <p:extLst>
     <p:ext uri="{521415D9-36F7-43E2-AB2F-B90AF26B5E84}">
       <p14:sectionLst xmlns:p14="http://schemas.microsoft.com/office/powerpoint/2010/main">
-        <p14:section name="Introduction" id="{aeb14b7f-2b05-2e5c-3a94-b9bbfee3ceba}">
+        <p14:section name="Introduction" id="{a85fa7b4-031c-b458-0b72-9d13f7b06c33}">
           <p14:sldIdLst>
             <p14:sldId id="256"/>
             <p14:sldId id="257"/>
           </p14:sldIdLst>
         </p14:section>
-        <p14:section name="Design" id="{5192df4c-d9f0-b796-9bcd-36c1623f96f3}">
+        <p14:section name="Design" id="{20f0cd46-d5f0-910d-7005-5f73abb89461}">
           <p14:sldIdLst>
             <p14:sldId id="258"/>
             <p14:sldId id="259"/>
           </p14:sldIdLst>
         </p14:section>
-        <p14:section name="Run" id="{5459312a-9eb0-ae91-4d41-7f97f4fb5aad}">
+        <p14:section name="Run" id="{5cefa2b4-a362-17c5-5aa0-e0090561d0c2}">
           <p14:sldIdLst>
             <p14:sldId id="260"/>
           </p14:sldIdLst>
@@ -4270,8 +4270,8 @@
         </p:nvSpPr>
         <p:spPr>
           <a:xfrm>
-            <a:off x="640080" y="1261872"/>
-            <a:ext cx="457200" cy="457200"/>
+            <a:off x="640080" y="1216152"/>
+            <a:ext cx="438912" cy="438912"/>
           </a:xfrm>
           <a:prstGeom prst="ellipse">
             <a:avLst/>
@@ -4298,8 +4298,8 @@
         </p:blipFill>
         <p:spPr>
           <a:xfrm>
-            <a:off x="754380" y="1376172"/>
-            <a:ext cx="228600" cy="228600"/>
+            <a:off x="749808" y="1325880"/>
+            <a:ext cx="219456" cy="219456"/>
           </a:xfrm>
           <a:prstGeom prst="rect">
             <a:avLst/>
@@ -4314,8 +4314,8 @@
         </p:nvSpPr>
         <p:spPr>
           <a:xfrm>
-            <a:off x="1207008" y="1216152"/>
-            <a:ext cx="1691640" cy="548640"/>
+            <a:off x="1188720" y="1216152"/>
+            <a:ext cx="1691640" cy="438912"/>
           </a:xfrm>
           <a:prstGeom prst="rect">
             <a:avLst/>
@@ -4340,32 +4340,18 @@
             </a:r>
             <a:endParaRPr lang="en-US" sz="1600" dirty="0"/>
           </a:p>
-          <a:p>
-            <a:pPr indent="0" marL="0">
-              <a:buNone/>
-            </a:pPr>
-            <a:r>
-              <a:rPr lang="en-US" sz="1000" dirty="0">
-                <a:solidFill>
-                  <a:schemeClr val="tx2"/>
-                </a:solidFill>
-              </a:rPr>
-              <a:t>Player · MoveStrategy</a:t>
-            </a:r>
-            <a:endParaRPr lang="en-US" sz="1600" dirty="0"/>
-          </a:p>
-        </p:txBody>
-      </p:sp>
-      <p:sp>
-        <p:nvSpPr>
-          <p:cNvPr id="7" name="oop desc Abstraction"/>
+        </p:txBody>
+      </p:sp>
+      <p:sp>
+        <p:nvSpPr>
+          <p:cNvPr id="7" name="oop classes Abstraction"/>
           <p:cNvSpPr txBox="1"/>
           <p:nvPr/>
         </p:nvSpPr>
         <p:spPr>
           <a:xfrm>
-            <a:off x="640080" y="1856232"/>
-            <a:ext cx="2194560" cy="777240"/>
+            <a:off x="640080" y="1737360"/>
+            <a:ext cx="2240280" cy="411480"/>
           </a:xfrm>
           <a:prstGeom prst="rect">
             <a:avLst/>
@@ -4381,20 +4367,70 @@
               <a:buNone/>
             </a:pPr>
             <a:r>
-              <a:rPr lang="en-US" sz="1400" dirty="0">
+              <a:rPr lang="en-US" sz="1200" b="1" dirty="0">
+                <a:solidFill>
+                  <a:schemeClr val="accent4"/>
+                </a:solidFill>
+              </a:rPr>
+              <a:t>player › Player</a:t>
+            </a:r>
+            <a:endParaRPr lang="en-US" sz="1200" dirty="0"/>
+          </a:p>
+          <a:p>
+            <a:pPr indent="0" marL="0">
+              <a:buNone/>
+            </a:pPr>
+            <a:r>
+              <a:rPr lang="en-US" sz="1200" b="1" dirty="0">
+                <a:solidFill>
+                  <a:schemeClr val="accent4"/>
+                </a:solidFill>
+              </a:rPr>
+              <a:t>strategy › MoveStrategy</a:t>
+            </a:r>
+            <a:endParaRPr lang="en-US" sz="1200" dirty="0"/>
+          </a:p>
+        </p:txBody>
+      </p:sp>
+      <p:sp>
+        <p:nvSpPr>
+          <p:cNvPr id="8" name="oop desc Abstraction"/>
+          <p:cNvSpPr txBox="1"/>
+          <p:nvPr/>
+        </p:nvSpPr>
+        <p:spPr>
+          <a:xfrm>
+            <a:off x="640080" y="2176272"/>
+            <a:ext cx="2240280" cy="502920"/>
+          </a:xfrm>
+          <a:prstGeom prst="rect">
+            <a:avLst/>
+          </a:prstGeom>
+          <a:noFill/>
+          <a:ln/>
+        </p:spPr>
+        <p:txBody>
+          <a:bodyPr wrap="square" lIns="0" tIns="0" rIns="0" bIns="0" rtlCol="0" anchor="t"/>
+          <a:lstStyle/>
+          <a:p>
+            <a:pPr indent="0" marL="0">
+              <a:buNone/>
+            </a:pPr>
+            <a:r>
+              <a:rPr lang="en-US" sz="1300" dirty="0">
                 <a:solidFill>
                   <a:schemeClr val="tx1"/>
                 </a:solidFill>
               </a:rPr>
-              <a:t>Game only calls chooseMove(); details stay hidden</a:t>
-            </a:r>
-            <a:endParaRPr lang="en-US" sz="1400" dirty="0"/>
-          </a:p>
-        </p:txBody>
-      </p:sp>
-      <p:sp>
-        <p:nvSpPr>
-          <p:cNvPr id="8" name="oop card Encapsulation"/>
+              <a:t>Abstract class / interface hide how a move is chosen</a:t>
+            </a:r>
+            <a:endParaRPr lang="en-US" sz="1300" dirty="0"/>
+          </a:p>
+        </p:txBody>
+      </p:sp>
+      <p:sp>
+        <p:nvSpPr>
+          <p:cNvPr id="9" name="oop card Encapsulation"/>
           <p:cNvSpPr/>
           <p:nvPr/>
         </p:nvSpPr>
@@ -4416,14 +4452,14 @@
       </p:sp>
       <p:sp>
         <p:nvSpPr>
-          <p:cNvPr id="9" name="Encapsulation circle"/>
+          <p:cNvPr id="10" name="Encapsulation circle"/>
           <p:cNvSpPr/>
           <p:nvPr/>
         </p:nvSpPr>
         <p:spPr>
           <a:xfrm>
-            <a:off x="3474720" y="1261872"/>
-            <a:ext cx="457200" cy="457200"/>
+            <a:off x="3474720" y="1216152"/>
+            <a:ext cx="438912" cy="438912"/>
           </a:xfrm>
           <a:prstGeom prst="ellipse">
             <a:avLst/>
@@ -4436,7 +4472,7 @@
       </p:sp>
       <p:pic>
         <p:nvPicPr>
-          <p:cNvPr id="10" name="Encapsulation icon" descr="Encapsulation">    </p:cNvPr>
+          <p:cNvPr id="11" name="Encapsulation icon" descr="Encapsulation">    </p:cNvPr>
           <p:cNvPicPr>
             <a:picLocks noChangeAspect="1"/>
           </p:cNvPicPr>
@@ -4450,8 +4486,8 @@
         </p:blipFill>
         <p:spPr>
           <a:xfrm>
-            <a:off x="3589020" y="1376172"/>
-            <a:ext cx="228600" cy="228600"/>
+            <a:off x="3584448" y="1325880"/>
+            <a:ext cx="219456" cy="219456"/>
           </a:xfrm>
           <a:prstGeom prst="rect">
             <a:avLst/>
@@ -4460,14 +4496,14 @@
       </p:pic>
       <p:sp>
         <p:nvSpPr>
-          <p:cNvPr id="11" name="oop name Encapsulation"/>
+          <p:cNvPr id="12" name="oop name Encapsulation"/>
           <p:cNvSpPr txBox="1"/>
           <p:nvPr/>
         </p:nvSpPr>
         <p:spPr>
           <a:xfrm>
-            <a:off x="4041648" y="1216152"/>
-            <a:ext cx="1691640" cy="548640"/>
+            <a:off x="4023360" y="1216152"/>
+            <a:ext cx="1691640" cy="438912"/>
           </a:xfrm>
           <a:prstGeom prst="rect">
             <a:avLst/>
@@ -4492,32 +4528,18 @@
             </a:r>
             <a:endParaRPr lang="en-US" sz="1600" dirty="0"/>
           </a:p>
-          <a:p>
-            <a:pPr indent="0" marL="0">
-              <a:buNone/>
-            </a:pPr>
-            <a:r>
-              <a:rPr lang="en-US" sz="1000" dirty="0">
-                <a:solidFill>
-                  <a:schemeClr val="tx2"/>
-                </a:solidFill>
-              </a:rPr>
-              <a:t>Scoreboard · Game</a:t>
-            </a:r>
-            <a:endParaRPr lang="en-US" sz="1600" dirty="0"/>
-          </a:p>
-        </p:txBody>
-      </p:sp>
-      <p:sp>
-        <p:nvSpPr>
-          <p:cNvPr id="12" name="oop desc Encapsulation"/>
+        </p:txBody>
+      </p:sp>
+      <p:sp>
+        <p:nvSpPr>
+          <p:cNvPr id="13" name="oop classes Encapsulation"/>
           <p:cNvSpPr txBox="1"/>
           <p:nvPr/>
         </p:nvSpPr>
         <p:spPr>
           <a:xfrm>
-            <a:off x="3474720" y="1856232"/>
-            <a:ext cx="2194560" cy="777240"/>
+            <a:off x="3474720" y="1737360"/>
+            <a:ext cx="2240280" cy="411480"/>
           </a:xfrm>
           <a:prstGeom prst="rect">
             <a:avLst/>
@@ -4533,20 +4555,56 @@
               <a:buNone/>
             </a:pPr>
             <a:r>
-              <a:rPr lang="en-US" sz="1400" dirty="0">
+              <a:rPr lang="en-US" sz="1200" b="1" dirty="0">
+                <a:solidFill>
+                  <a:schemeClr val="accent4"/>
+                </a:solidFill>
+              </a:rPr>
+              <a:t>model › Scoreboard, Game</a:t>
+            </a:r>
+            <a:endParaRPr lang="en-US" sz="1200" dirty="0"/>
+          </a:p>
+        </p:txBody>
+      </p:sp>
+      <p:sp>
+        <p:nvSpPr>
+          <p:cNvPr id="14" name="oop desc Encapsulation"/>
+          <p:cNvSpPr txBox="1"/>
+          <p:nvPr/>
+        </p:nvSpPr>
+        <p:spPr>
+          <a:xfrm>
+            <a:off x="3474720" y="2176272"/>
+            <a:ext cx="2240280" cy="502920"/>
+          </a:xfrm>
+          <a:prstGeom prst="rect">
+            <a:avLst/>
+          </a:prstGeom>
+          <a:noFill/>
+          <a:ln/>
+        </p:spPr>
+        <p:txBody>
+          <a:bodyPr wrap="square" lIns="0" tIns="0" rIns="0" bIns="0" rtlCol="0" anchor="t"/>
+          <a:lstStyle/>
+          <a:p>
+            <a:pPr indent="0" marL="0">
+              <a:buNone/>
+            </a:pPr>
+            <a:r>
+              <a:rPr lang="en-US" sz="1300" dirty="0">
                 <a:solidFill>
                   <a:schemeClr val="tx1"/>
                 </a:solidFill>
               </a:rPr>
-              <a:t>Private fields; score changes only via record()</a:t>
-            </a:r>
-            <a:endParaRPr lang="en-US" sz="1400" dirty="0"/>
-          </a:p>
-        </p:txBody>
-      </p:sp>
-      <p:sp>
-        <p:nvSpPr>
-          <p:cNvPr id="13" name="oop card Inheritance"/>
+              <a:t>Private fields, changed only via record() / playRound()</a:t>
+            </a:r>
+            <a:endParaRPr lang="en-US" sz="1300" dirty="0"/>
+          </a:p>
+        </p:txBody>
+      </p:sp>
+      <p:sp>
+        <p:nvSpPr>
+          <p:cNvPr id="15" name="oop card Inheritance"/>
           <p:cNvSpPr/>
           <p:nvPr/>
         </p:nvSpPr>
@@ -4568,14 +4626,14 @@
       </p:sp>
       <p:sp>
         <p:nvSpPr>
-          <p:cNvPr id="14" name="Inheritance circle"/>
+          <p:cNvPr id="16" name="Inheritance circle"/>
           <p:cNvSpPr/>
           <p:nvPr/>
         </p:nvSpPr>
         <p:spPr>
           <a:xfrm>
-            <a:off x="6309360" y="1261872"/>
-            <a:ext cx="457200" cy="457200"/>
+            <a:off x="6309360" y="1216152"/>
+            <a:ext cx="438912" cy="438912"/>
           </a:xfrm>
           <a:prstGeom prst="ellipse">
             <a:avLst/>
@@ -4588,7 +4646,7 @@
       </p:sp>
       <p:pic>
         <p:nvPicPr>
-          <p:cNvPr id="15" name="Inheritance icon" descr="Inheritance">    </p:cNvPr>
+          <p:cNvPr id="17" name="Inheritance icon" descr="Inheritance">    </p:cNvPr>
           <p:cNvPicPr>
             <a:picLocks noChangeAspect="1"/>
           </p:cNvPicPr>
@@ -4602,8 +4660,8 @@
         </p:blipFill>
         <p:spPr>
           <a:xfrm>
-            <a:off x="6423660" y="1376172"/>
-            <a:ext cx="228600" cy="228600"/>
+            <a:off x="6419088" y="1325880"/>
+            <a:ext cx="219456" cy="219456"/>
           </a:xfrm>
           <a:prstGeom prst="rect">
             <a:avLst/>
@@ -4612,14 +4670,14 @@
       </p:pic>
       <p:sp>
         <p:nvSpPr>
-          <p:cNvPr id="16" name="oop name Inheritance"/>
+          <p:cNvPr id="18" name="oop name Inheritance"/>
           <p:cNvSpPr txBox="1"/>
           <p:nvPr/>
         </p:nvSpPr>
         <p:spPr>
           <a:xfrm>
-            <a:off x="6876288" y="1216152"/>
-            <a:ext cx="1691640" cy="548640"/>
+            <a:off x="6858000" y="1216152"/>
+            <a:ext cx="1691640" cy="438912"/>
           </a:xfrm>
           <a:prstGeom prst="rect">
             <a:avLst/>
@@ -4644,32 +4702,18 @@
             </a:r>
             <a:endParaRPr lang="en-US" sz="1600" dirty="0"/>
           </a:p>
-          <a:p>
-            <a:pPr indent="0" marL="0">
-              <a:buNone/>
-            </a:pPr>
-            <a:r>
-              <a:rPr lang="en-US" sz="1000" dirty="0">
-                <a:solidFill>
-                  <a:schemeClr val="tx2"/>
-                </a:solidFill>
-              </a:rPr>
-              <a:t>HumanPlayer · ComputerPlayer</a:t>
-            </a:r>
-            <a:endParaRPr lang="en-US" sz="1600" dirty="0"/>
-          </a:p>
-        </p:txBody>
-      </p:sp>
-      <p:sp>
-        <p:nvSpPr>
-          <p:cNvPr id="17" name="oop desc Inheritance"/>
+        </p:txBody>
+      </p:sp>
+      <p:sp>
+        <p:nvSpPr>
+          <p:cNvPr id="19" name="oop classes Inheritance"/>
           <p:cNvSpPr txBox="1"/>
           <p:nvPr/>
         </p:nvSpPr>
         <p:spPr>
           <a:xfrm>
-            <a:off x="6309360" y="1856232"/>
-            <a:ext cx="2194560" cy="777240"/>
+            <a:off x="6309360" y="1737360"/>
+            <a:ext cx="2240280" cy="411480"/>
           </a:xfrm>
           <a:prstGeom prst="rect">
             <a:avLst/>
@@ -4685,20 +4729,56 @@
               <a:buNone/>
             </a:pPr>
             <a:r>
-              <a:rPr lang="en-US" sz="1400" dirty="0">
+              <a:rPr lang="en-US" sz="1200" b="1" dirty="0">
+                <a:solidFill>
+                  <a:schemeClr val="accent4"/>
+                </a:solidFill>
+              </a:rPr>
+              <a:t>player › HumanPlayer, ComputerPlayer</a:t>
+            </a:r>
+            <a:endParaRPr lang="en-US" sz="1200" dirty="0"/>
+          </a:p>
+        </p:txBody>
+      </p:sp>
+      <p:sp>
+        <p:nvSpPr>
+          <p:cNvPr id="20" name="oop desc Inheritance"/>
+          <p:cNvSpPr txBox="1"/>
+          <p:nvPr/>
+        </p:nvSpPr>
+        <p:spPr>
+          <a:xfrm>
+            <a:off x="6309360" y="2176272"/>
+            <a:ext cx="2240280" cy="502920"/>
+          </a:xfrm>
+          <a:prstGeom prst="rect">
+            <a:avLst/>
+          </a:prstGeom>
+          <a:noFill/>
+          <a:ln/>
+        </p:spPr>
+        <p:txBody>
+          <a:bodyPr wrap="square" lIns="0" tIns="0" rIns="0" bIns="0" rtlCol="0" anchor="t"/>
+          <a:lstStyle/>
+          <a:p>
+            <a:pPr indent="0" marL="0">
+              <a:buNone/>
+            </a:pPr>
+            <a:r>
+              <a:rPr lang="en-US" sz="1300" dirty="0">
                 <a:solidFill>
                   <a:schemeClr val="tx1"/>
                 </a:solidFill>
               </a:rPr>
-              <a:t>Both extend the abstract Player class</a:t>
-            </a:r>
-            <a:endParaRPr lang="en-US" sz="1400" dirty="0"/>
-          </a:p>
-        </p:txBody>
-      </p:sp>
-      <p:sp>
-        <p:nvSpPr>
-          <p:cNvPr id="18" name="oop card Polymorphism"/>
+              <a:t>Both extend Player and override chooseMove()</a:t>
+            </a:r>
+            <a:endParaRPr lang="en-US" sz="1300" dirty="0"/>
+          </a:p>
+        </p:txBody>
+      </p:sp>
+      <p:sp>
+        <p:nvSpPr>
+          <p:cNvPr id="21" name="oop card Polymorphism"/>
           <p:cNvSpPr/>
           <p:nvPr/>
         </p:nvSpPr>
@@ -4720,14 +4800,14 @@
       </p:sp>
       <p:sp>
         <p:nvSpPr>
-          <p:cNvPr id="19" name="Polymorphism circle"/>
+          <p:cNvPr id="22" name="Polymorphism circle"/>
           <p:cNvSpPr/>
           <p:nvPr/>
         </p:nvSpPr>
         <p:spPr>
           <a:xfrm>
-            <a:off x="640080" y="3108960"/>
-            <a:ext cx="457200" cy="457200"/>
+            <a:off x="640080" y="3063240"/>
+            <a:ext cx="438912" cy="438912"/>
           </a:xfrm>
           <a:prstGeom prst="ellipse">
             <a:avLst/>
@@ -4740,7 +4820,7 @@
       </p:sp>
       <p:pic>
         <p:nvPicPr>
-          <p:cNvPr id="20" name="Polymorphism icon" descr="Polymorphism">    </p:cNvPr>
+          <p:cNvPr id="23" name="Polymorphism icon" descr="Polymorphism">    </p:cNvPr>
           <p:cNvPicPr>
             <a:picLocks noChangeAspect="1"/>
           </p:cNvPicPr>
@@ -4754,8 +4834,8 @@
         </p:blipFill>
         <p:spPr>
           <a:xfrm>
-            <a:off x="754380" y="3223260"/>
-            <a:ext cx="228600" cy="228600"/>
+            <a:off x="749808" y="3172968"/>
+            <a:ext cx="219456" cy="219456"/>
           </a:xfrm>
           <a:prstGeom prst="rect">
             <a:avLst/>
@@ -4764,14 +4844,14 @@
       </p:pic>
       <p:sp>
         <p:nvSpPr>
-          <p:cNvPr id="21" name="oop name Polymorphism"/>
+          <p:cNvPr id="24" name="oop name Polymorphism"/>
           <p:cNvSpPr txBox="1"/>
           <p:nvPr/>
         </p:nvSpPr>
         <p:spPr>
           <a:xfrm>
-            <a:off x="1207008" y="3063240"/>
-            <a:ext cx="1691640" cy="548640"/>
+            <a:off x="1188720" y="3063240"/>
+            <a:ext cx="1691640" cy="438912"/>
           </a:xfrm>
           <a:prstGeom prst="rect">
             <a:avLst/>
@@ -4796,32 +4876,18 @@
             </a:r>
             <a:endParaRPr lang="en-US" sz="1600" dirty="0"/>
           </a:p>
-          <a:p>
-            <a:pPr indent="0" marL="0">
-              <a:buNone/>
-            </a:pPr>
-            <a:r>
-              <a:rPr lang="en-US" sz="1000" dirty="0">
-                <a:solidFill>
-                  <a:schemeClr val="tx2"/>
-                </a:solidFill>
-              </a:rPr>
-              <a:t>chooseMove() · nextMove()</a:t>
-            </a:r>
-            <a:endParaRPr lang="en-US" sz="1600" dirty="0"/>
-          </a:p>
-        </p:txBody>
-      </p:sp>
-      <p:sp>
-        <p:nvSpPr>
-          <p:cNvPr id="22" name="oop desc Polymorphism"/>
+        </p:txBody>
+      </p:sp>
+      <p:sp>
+        <p:nvSpPr>
+          <p:cNvPr id="25" name="oop classes Polymorphism"/>
           <p:cNvSpPr txBox="1"/>
           <p:nvPr/>
         </p:nvSpPr>
         <p:spPr>
           <a:xfrm>
-            <a:off x="640080" y="3703320"/>
-            <a:ext cx="2194560" cy="777240"/>
+            <a:off x="640080" y="3584448"/>
+            <a:ext cx="2240280" cy="411480"/>
           </a:xfrm>
           <a:prstGeom prst="rect">
             <a:avLst/>
@@ -4837,20 +4903,70 @@
               <a:buNone/>
             </a:pPr>
             <a:r>
-              <a:rPr lang="en-US" sz="1400" dirty="0">
+              <a:rPr lang="en-US" sz="1200" b="1" dirty="0">
+                <a:solidFill>
+                  <a:schemeClr val="accent4"/>
+                </a:solidFill>
+              </a:rPr>
+              <a:t>Player.chooseMove()</a:t>
+            </a:r>
+            <a:endParaRPr lang="en-US" sz="1200" dirty="0"/>
+          </a:p>
+          <a:p>
+            <a:pPr indent="0" marL="0">
+              <a:buNone/>
+            </a:pPr>
+            <a:r>
+              <a:rPr lang="en-US" sz="1200" b="1" dirty="0">
+                <a:solidFill>
+                  <a:schemeClr val="accent4"/>
+                </a:solidFill>
+              </a:rPr>
+              <a:t>MoveStrategy.nextMove()</a:t>
+            </a:r>
+            <a:endParaRPr lang="en-US" sz="1200" dirty="0"/>
+          </a:p>
+        </p:txBody>
+      </p:sp>
+      <p:sp>
+        <p:nvSpPr>
+          <p:cNvPr id="26" name="oop desc Polymorphism"/>
+          <p:cNvSpPr txBox="1"/>
+          <p:nvPr/>
+        </p:nvSpPr>
+        <p:spPr>
+          <a:xfrm>
+            <a:off x="640080" y="4023360"/>
+            <a:ext cx="2240280" cy="502920"/>
+          </a:xfrm>
+          <a:prstGeom prst="rect">
+            <a:avLst/>
+          </a:prstGeom>
+          <a:noFill/>
+          <a:ln/>
+        </p:spPr>
+        <p:txBody>
+          <a:bodyPr wrap="square" lIns="0" tIns="0" rIns="0" bIns="0" rtlCol="0" anchor="t"/>
+          <a:lstStyle/>
+          <a:p>
+            <a:pPr indent="0" marL="0">
+              <a:buNone/>
+            </a:pPr>
+            <a:r>
+              <a:rPr lang="en-US" sz="1300" dirty="0">
                 <a:solidFill>
                   <a:schemeClr val="tx1"/>
                 </a:solidFill>
               </a:rPr>
-              <a:t>Same call, different behaviour per object</a:t>
-            </a:r>
-            <a:endParaRPr lang="en-US" sz="1400" dirty="0"/>
-          </a:p>
-        </p:txBody>
-      </p:sp>
-      <p:sp>
-        <p:nvSpPr>
-          <p:cNvPr id="23" name="oop card Composition"/>
+              <a:t>Same call, different behaviour per subclass</a:t>
+            </a:r>
+            <a:endParaRPr lang="en-US" sz="1300" dirty="0"/>
+          </a:p>
+        </p:txBody>
+      </p:sp>
+      <p:sp>
+        <p:nvSpPr>
+          <p:cNvPr id="27" name="oop card Composition"/>
           <p:cNvSpPr/>
           <p:nvPr/>
         </p:nvSpPr>
@@ -4872,14 +4988,14 @@
       </p:sp>
       <p:sp>
         <p:nvSpPr>
-          <p:cNvPr id="24" name="Composition circle"/>
+          <p:cNvPr id="28" name="Composition circle"/>
           <p:cNvSpPr/>
           <p:nvPr/>
         </p:nvSpPr>
         <p:spPr>
           <a:xfrm>
-            <a:off x="3474720" y="3108960"/>
-            <a:ext cx="457200" cy="457200"/>
+            <a:off x="3474720" y="3063240"/>
+            <a:ext cx="438912" cy="438912"/>
           </a:xfrm>
           <a:prstGeom prst="ellipse">
             <a:avLst/>
@@ -4892,7 +5008,7 @@
       </p:sp>
       <p:pic>
         <p:nvPicPr>
-          <p:cNvPr id="25" name="Composition icon" descr="Composition">    </p:cNvPr>
+          <p:cNvPr id="29" name="Composition icon" descr="Composition">    </p:cNvPr>
           <p:cNvPicPr>
             <a:picLocks noChangeAspect="1"/>
           </p:cNvPicPr>
@@ -4906,8 +5022,8 @@
         </p:blipFill>
         <p:spPr>
           <a:xfrm>
-            <a:off x="3589020" y="3223260"/>
-            <a:ext cx="228600" cy="228600"/>
+            <a:off x="3584448" y="3172968"/>
+            <a:ext cx="219456" cy="219456"/>
           </a:xfrm>
           <a:prstGeom prst="rect">
             <a:avLst/>
@@ -4916,14 +5032,14 @@
       </p:pic>
       <p:sp>
         <p:nvSpPr>
-          <p:cNvPr id="26" name="oop name Composition"/>
+          <p:cNvPr id="30" name="oop name Composition"/>
           <p:cNvSpPr txBox="1"/>
           <p:nvPr/>
         </p:nvSpPr>
         <p:spPr>
           <a:xfrm>
-            <a:off x="4041648" y="3063240"/>
-            <a:ext cx="1691640" cy="548640"/>
+            <a:off x="4023360" y="3063240"/>
+            <a:ext cx="1691640" cy="438912"/>
           </a:xfrm>
           <a:prstGeom prst="rect">
             <a:avLst/>
@@ -4948,32 +5064,18 @@
             </a:r>
             <a:endParaRPr lang="en-US" sz="1600" dirty="0"/>
           </a:p>
-          <a:p>
-            <a:pPr indent="0" marL="0">
-              <a:buNone/>
-            </a:pPr>
-            <a:r>
-              <a:rPr lang="en-US" sz="1000" dirty="0">
-                <a:solidFill>
-                  <a:schemeClr val="tx2"/>
-                </a:solidFill>
-              </a:rPr>
-              <a:t>Game · ComputerPlayer</a:t>
-            </a:r>
-            <a:endParaRPr lang="en-US" sz="1600" dirty="0"/>
-          </a:p>
-        </p:txBody>
-      </p:sp>
-      <p:sp>
-        <p:nvSpPr>
-          <p:cNvPr id="27" name="oop desc Composition"/>
+        </p:txBody>
+      </p:sp>
+      <p:sp>
+        <p:nvSpPr>
+          <p:cNvPr id="31" name="oop classes Composition"/>
           <p:cNvSpPr txBox="1"/>
           <p:nvPr/>
         </p:nvSpPr>
         <p:spPr>
           <a:xfrm>
-            <a:off x="3474720" y="3703320"/>
-            <a:ext cx="2194560" cy="777240"/>
+            <a:off x="3474720" y="3584448"/>
+            <a:ext cx="2240280" cy="411480"/>
           </a:xfrm>
           <a:prstGeom prst="rect">
             <a:avLst/>
@@ -4989,20 +5091,70 @@
               <a:buNone/>
             </a:pPr>
             <a:r>
-              <a:rPr lang="en-US" sz="1400" dirty="0">
+              <a:rPr lang="en-US" sz="1200" b="1" dirty="0">
+                <a:solidFill>
+                  <a:schemeClr val="accent4"/>
+                </a:solidFill>
+              </a:rPr>
+              <a:t>model › Game</a:t>
+            </a:r>
+            <a:endParaRPr lang="en-US" sz="1200" dirty="0"/>
+          </a:p>
+          <a:p>
+            <a:pPr indent="0" marL="0">
+              <a:buNone/>
+            </a:pPr>
+            <a:r>
+              <a:rPr lang="en-US" sz="1200" b="1" dirty="0">
+                <a:solidFill>
+                  <a:schemeClr val="accent4"/>
+                </a:solidFill>
+              </a:rPr>
+              <a:t>player › ComputerPlayer</a:t>
+            </a:r>
+            <a:endParaRPr lang="en-US" sz="1200" dirty="0"/>
+          </a:p>
+        </p:txBody>
+      </p:sp>
+      <p:sp>
+        <p:nvSpPr>
+          <p:cNvPr id="32" name="oop desc Composition"/>
+          <p:cNvSpPr txBox="1"/>
+          <p:nvPr/>
+        </p:nvSpPr>
+        <p:spPr>
+          <a:xfrm>
+            <a:off x="3474720" y="4023360"/>
+            <a:ext cx="2240280" cy="502920"/>
+          </a:xfrm>
+          <a:prstGeom prst="rect">
+            <a:avLst/>
+          </a:prstGeom>
+          <a:noFill/>
+          <a:ln/>
+        </p:spPr>
+        <p:txBody>
+          <a:bodyPr wrap="square" lIns="0" tIns="0" rIns="0" bIns="0" rtlCol="0" anchor="t"/>
+          <a:lstStyle/>
+          <a:p>
+            <a:pPr indent="0" marL="0">
+              <a:buNone/>
+            </a:pPr>
+            <a:r>
+              <a:rPr lang="en-US" sz="1300" dirty="0">
                 <a:solidFill>
                   <a:schemeClr val="tx1"/>
                 </a:solidFill>
               </a:rPr>
-              <a:t>Game has players, a score and rounds</a:t>
-            </a:r>
-            <a:endParaRPr lang="en-US" sz="1400" dirty="0"/>
-          </a:p>
-        </p:txBody>
-      </p:sp>
-      <p:sp>
-        <p:nvSpPr>
-          <p:cNvPr id="28" name="oop card Strategy pattern"/>
+              <a:t>Game has players + score; ComputerPlayer has a strategy</a:t>
+            </a:r>
+            <a:endParaRPr lang="en-US" sz="1300" dirty="0"/>
+          </a:p>
+        </p:txBody>
+      </p:sp>
+      <p:sp>
+        <p:nvSpPr>
+          <p:cNvPr id="33" name="oop card Strategy pattern"/>
           <p:cNvSpPr/>
           <p:nvPr/>
         </p:nvSpPr>
@@ -5024,14 +5176,14 @@
       </p:sp>
       <p:sp>
         <p:nvSpPr>
-          <p:cNvPr id="29" name="Strategy pattern circle"/>
+          <p:cNvPr id="34" name="Strategy pattern circle"/>
           <p:cNvSpPr/>
           <p:nvPr/>
         </p:nvSpPr>
         <p:spPr>
           <a:xfrm>
-            <a:off x="6309360" y="3108960"/>
-            <a:ext cx="457200" cy="457200"/>
+            <a:off x="6309360" y="3063240"/>
+            <a:ext cx="438912" cy="438912"/>
           </a:xfrm>
           <a:prstGeom prst="ellipse">
             <a:avLst/>
@@ -5044,7 +5196,7 @@
       </p:sp>
       <p:pic>
         <p:nvPicPr>
-          <p:cNvPr id="30" name="Strategy pattern icon" descr="Strategy pattern">    </p:cNvPr>
+          <p:cNvPr id="35" name="Strategy pattern icon" descr="Strategy pattern">    </p:cNvPr>
           <p:cNvPicPr>
             <a:picLocks noChangeAspect="1"/>
           </p:cNvPicPr>
@@ -5058,8 +5210,8 @@
         </p:blipFill>
         <p:spPr>
           <a:xfrm>
-            <a:off x="6423660" y="3223260"/>
-            <a:ext cx="228600" cy="228600"/>
+            <a:off x="6419088" y="3172968"/>
+            <a:ext cx="219456" cy="219456"/>
           </a:xfrm>
           <a:prstGeom prst="rect">
             <a:avLst/>
@@ -5068,14 +5220,14 @@
       </p:pic>
       <p:sp>
         <p:nvSpPr>
-          <p:cNvPr id="31" name="oop name Strategy pattern"/>
+          <p:cNvPr id="36" name="oop name Strategy pattern"/>
           <p:cNvSpPr txBox="1"/>
           <p:nvPr/>
         </p:nvSpPr>
         <p:spPr>
           <a:xfrm>
-            <a:off x="6876288" y="3063240"/>
-            <a:ext cx="1691640" cy="548640"/>
+            <a:off x="6858000" y="3063240"/>
+            <a:ext cx="1691640" cy="438912"/>
           </a:xfrm>
           <a:prstGeom prst="rect">
             <a:avLst/>
@@ -5100,32 +5252,18 @@
             </a:r>
             <a:endParaRPr lang="en-US" sz="1600" dirty="0"/>
           </a:p>
-          <a:p>
-            <a:pPr indent="0" marL="0">
-              <a:buNone/>
-            </a:pPr>
-            <a:r>
-              <a:rPr lang="en-US" sz="1000" dirty="0">
-                <a:solidFill>
-                  <a:schemeClr val="tx2"/>
-                </a:solidFill>
-              </a:rPr>
-              <a:t>ComputerPlayer + MoveStrategy</a:t>
-            </a:r>
-            <a:endParaRPr lang="en-US" sz="1600" dirty="0"/>
-          </a:p>
-        </p:txBody>
-      </p:sp>
-      <p:sp>
-        <p:nvSpPr>
-          <p:cNvPr id="32" name="oop desc Strategy pattern"/>
+        </p:txBody>
+      </p:sp>
+      <p:sp>
+        <p:nvSpPr>
+          <p:cNvPr id="37" name="oop classes Strategy pattern"/>
           <p:cNvSpPr txBox="1"/>
           <p:nvPr/>
         </p:nvSpPr>
         <p:spPr>
           <a:xfrm>
-            <a:off x="6309360" y="3703320"/>
-            <a:ext cx="2194560" cy="777240"/>
+            <a:off x="6309360" y="3584448"/>
+            <a:ext cx="2240280" cy="411480"/>
           </a:xfrm>
           <a:prstGeom prst="rect">
             <a:avLst/>
@@ -5141,14 +5279,50 @@
               <a:buNone/>
             </a:pPr>
             <a:r>
-              <a:rPr lang="en-US" sz="1400" dirty="0">
+              <a:rPr lang="en-US" sz="1200" b="1" dirty="0">
+                <a:solidFill>
+                  <a:schemeClr val="accent4"/>
+                </a:solidFill>
+              </a:rPr>
+              <a:t>strategy › RandomStrategy, FrequencyStrategy</a:t>
+            </a:r>
+            <a:endParaRPr lang="en-US" sz="1200" dirty="0"/>
+          </a:p>
+        </p:txBody>
+      </p:sp>
+      <p:sp>
+        <p:nvSpPr>
+          <p:cNvPr id="38" name="oop desc Strategy pattern"/>
+          <p:cNvSpPr txBox="1"/>
+          <p:nvPr/>
+        </p:nvSpPr>
+        <p:spPr>
+          <a:xfrm>
+            <a:off x="6309360" y="4023360"/>
+            <a:ext cx="2240280" cy="502920"/>
+          </a:xfrm>
+          <a:prstGeom prst="rect">
+            <a:avLst/>
+          </a:prstGeom>
+          <a:noFill/>
+          <a:ln/>
+        </p:spPr>
+        <p:txBody>
+          <a:bodyPr wrap="square" lIns="0" tIns="0" rIns="0" bIns="0" rtlCol="0" anchor="t"/>
+          <a:lstStyle/>
+          <a:p>
+            <a:pPr indent="0" marL="0">
+              <a:buNone/>
+            </a:pPr>
+            <a:r>
+              <a:rPr lang="en-US" sz="1300" dirty="0">
                 <a:solidFill>
                   <a:schemeClr val="tx1"/>
                 </a:solidFill>
               </a:rPr>
-              <a:t>Swap the AI without touching other code</a:t>
-            </a:r>
-            <a:endParaRPr lang="en-US" sz="1400" dirty="0"/>
+              <a:t>Easy / Hard AI swapped without changing ComputerPlayer</a:t>
+            </a:r>
+            <a:endParaRPr lang="en-US" sz="1300" dirty="0"/>
           </a:p>
         </p:txBody>
       </p:sp>

</xml_diff>